<commit_message>
Widen title/subtitle placeholders on TITLE_AND_BODY layout
The title and summary placeholders were far narrower than the slide
width (7.85" and 5.81" right edges on a 10" slide), causing long
titles to wrap to a second line that visually collided with the
summary text pinned directly below it.
</commit_message>
<xml_diff>
--- a/slides/template.pptx
+++ b/slides/template.pptx
@@ -9962,7 +9962,7 @@
         <p:spPr>
           <a:xfrm>
             <a:off x="548050" y="328157"/>
-            <a:ext cx="6633000" cy="806700"/>
+            <a:ext cx="8047900" cy="806700"/>
           </a:xfrm>
           <a:prstGeom prst="rect">
             <a:avLst/>
@@ -10713,7 +10713,7 @@
         <p:spPr>
           <a:xfrm>
             <a:off x="548050" y="763432"/>
-            <a:ext cx="4763400" cy="341100"/>
+            <a:ext cx="8047900" cy="341100"/>
           </a:xfrm>
           <a:prstGeom prst="rect">
             <a:avLst/>

</xml_diff>